<commit_message>
Brand: "Skin Tyee" (two words); drop the placeholder bird from the logo
- Logo is now a plain text wordmark "Skin Tyee" — removed the invented bird
  icon, which was never the Nation's real logo. Still a placeholder until a
  real logo asset is supplied.
- Fix the displayed band/app name to "Skin Tyee" (two words): header, splash,
  app.config name, Config.appName.
- Update display-name references across docs + the proposal deck to
  "Skin Tyee" / "Skin Tyee First Nation" (technical tokens skintyee.ca,
  @skintyee, paths, and the .pptx filename left unchanged). Deck regenerated.

Typecheck passes; web compiles.

Co-Authored-By: Claude Opus 4.7 (1M context) <noreply@anthropic.com>
</commit_message>
<xml_diff>
--- a/docs/Skintyee-App-Proposal.pptx
+++ b/docs/Skintyee-App-Proposal.pptx
@@ -3226,7 +3226,7 @@
                 </a:solidFill>
                 <a:latin typeface="Arial"/>
               </a:rPr>
-              <a:t>Skintyee First Nation</a:t>
+              <a:t>Skin Tyee First Nation</a:t>
             </a:r>
           </a:p>
         </p:txBody>
@@ -3631,7 +3631,7 @@
                 </a:solidFill>
                 <a:latin typeface="Arial"/>
               </a:rPr>
-              <a:t>a single mobile + web app for the Skintyee First Nation community.</a:t>
+              <a:t>a single mobile + web app for the Skin Tyee First Nation community.</a:t>
             </a:r>
           </a:p>
           <a:p>
@@ -6780,7 +6780,7 @@
                 </a:solidFill>
                 <a:latin typeface="Arial"/>
               </a:rPr>
-              <a:t>Skintyee App</a:t>
+              <a:t>Skin Tyee App</a:t>
             </a:r>
           </a:p>
         </p:txBody>
@@ -10279,7 +10279,7 @@
                 </a:solidFill>
                 <a:latin typeface="Arial"/>
               </a:rPr>
-              <a:t>for the Skintyee First Nation community.</a:t>
+              <a:t>for the Skin Tyee First Nation community.</a:t>
             </a:r>
           </a:p>
         </p:txBody>

</xml_diff>